<commit_message>
docs: inventory Node.js, Cordova, and client packages
Add docs/packages.md, link it from the README, and include a
packages slide in the Week 12 deck so the presentation covers
assignment-relevant libraries and plugins.

Co-authored-by: Anthony Naui <nauijohn@users.noreply.github.com>
</commit_message>
<xml_diff>
--- a/docs/slides/StudySwap-Week12-Presentation.pptx
+++ b/docs/slides/StudySwap-Week12-Presentation.pptx
@@ -15,9 +15,10 @@
     <p:sldId id="263" r:id="rId9"/>
     <p:sldId id="264" r:id="rId10"/>
     <p:sldId id="265" r:id="rId11"/>
+    <p:sldId id="266" r:id="rId12"/>
   </p:sldIdLst>
   <p:notesMasterIdLst>
-    <p:notesMasterId r:id="rId12"/>
+    <p:notesMasterId r:id="rId13"/>
   </p:notesMasterIdLst>
   <p:sldSz cx="12191695" cy="6858000"/>
   <p:notesSz cx="6858000" cy="12191695"/>
@@ -599,7 +600,7 @@
           <a:p>
             <a:r>
               <a:rPr lang="en-US" dirty="0"/>
-              <a:t>Handoff to demo. John: lead/docs/BE-FE; Yavik: Atlas/Render; Linh: app shell/theme. Reminder: understanding is assessed individually.</a:t>
+              <a:t>Assignment values Cordova plugins and Node packages. Point to docs/packages.md for the full table. Emphasize camera plugin + Passport/bcrypt/JWT/Mongoose as the main extras.</a:t>
             </a:r>
             <a:endParaRPr lang="en-US" dirty="0"/>
           </a:p>
@@ -623,6 +624,94 @@
             <a:fld id="{F7021451-1387-4CA6-816F-3879F97B5CBC}" type="slidenum">
               <a:rPr lang="en-US"/>
               <a:t>10</a:t>
+            </a:fld>
+            <a:endParaRPr lang="en-US"/>
+          </a:p>
+        </p:txBody>
+      </p:sp>
+    </p:spTree>
+    <p:extLst>
+      <p:ext uri="{BB962C8B-B14F-4D97-AF65-F5344CB8AC3E}">
+        <p14:creationId xmlns:p14="http://schemas.microsoft.com/office/powerpoint/2010/main" val="1024086991"/>
+      </p:ext>
+    </p:extLst>
+  </p:cSld>
+  <p:clrMapOvr>
+    <a:masterClrMapping/>
+  </p:clrMapOvr>
+</p:notes>
+</file>
+
+<file path=ppt/notesSlides/notesSlide11.xml><?xml version="1.0" encoding="utf-8"?>
+<p:notes xmlns:a="http://schemas.openxmlformats.org/drawingml/2006/main" xmlns:r="http://schemas.openxmlformats.org/officeDocument/2006/relationships" xmlns:p="http://schemas.openxmlformats.org/presentationml/2006/main">
+  <p:cSld>
+    <p:spTree>
+      <p:nvGrpSpPr>
+        <p:cNvPr id="1" name=""/>
+        <p:cNvGrpSpPr/>
+        <p:nvPr/>
+      </p:nvGrpSpPr>
+      <p:grpSpPr>
+        <a:xfrm>
+          <a:off x="0" y="0"/>
+          <a:ext cx="0" cy="0"/>
+          <a:chOff x="0" y="0"/>
+          <a:chExt cx="0" cy="0"/>
+        </a:xfrm>
+      </p:grpSpPr>
+      <p:sp>
+        <p:nvSpPr>
+          <p:cNvPr id="2" name="Slide Image Placeholder 1"/>
+          <p:cNvSpPr>
+            <a:spLocks noGrp="1" noRot="1" noChangeAspect="1"/>
+          </p:cNvSpPr>
+          <p:nvPr>
+            <p:ph type="sldImg"/>
+          </p:nvPr>
+        </p:nvSpPr>
+        <p:spPr/>
+      </p:sp>
+      <p:sp>
+        <p:nvSpPr>
+          <p:cNvPr id="3" name="Notes Placeholder 2"/>
+          <p:cNvSpPr>
+            <a:spLocks noGrp="1"/>
+          </p:cNvSpPr>
+          <p:nvPr>
+            <p:ph type="body" idx="1"/>
+          </p:nvPr>
+        </p:nvSpPr>
+        <p:spPr/>
+        <p:txBody>
+          <a:bodyPr/>
+          <a:lstStyle/>
+          <a:p>
+            <a:r>
+              <a:rPr lang="en-US" dirty="0"/>
+              <a:t>Handoff to demo. John: lead/docs/BE-FE; Yavik: Atlas/Render; Linh: app shell/theme. Reminder: understanding is assessed individually.</a:t>
+            </a:r>
+            <a:endParaRPr lang="en-US" dirty="0"/>
+          </a:p>
+        </p:txBody>
+      </p:sp>
+      <p:sp>
+        <p:nvSpPr>
+          <p:cNvPr id="4" name="Slide Number Placeholder 3"/>
+          <p:cNvSpPr>
+            <a:spLocks noGrp="1"/>
+          </p:cNvSpPr>
+          <p:nvPr>
+            <p:ph type="sldNum" sz="quarter" idx="10"/>
+          </p:nvPr>
+        </p:nvSpPr>
+        <p:spPr/>
+        <p:txBody>
+          <a:bodyPr/>
+          <a:lstStyle/>
+          <a:p>
+            <a:fld id="{F7021451-1387-4CA6-816F-3879F97B5CBC}" type="slidenum">
+              <a:rPr lang="en-US"/>
+              <a:t>11</a:t>
             </a:fld>
             <a:endParaRPr lang="en-US"/>
           </a:p>
@@ -1890,14 +1979,114 @@
       </p:sp>
       <p:sp>
         <p:nvSpPr>
-          <p:cNvPr id="3" name="Shape 1"/>
-          <p:cNvSpPr/>
-          <p:nvPr/>
-        </p:nvSpPr>
-        <p:spPr>
-          <a:xfrm>
-            <a:off x="0" y="0"/>
-            <a:ext cx="228600" cy="6858000"/>
+          <p:cNvPr id="3" name="Text 1"/>
+          <p:cNvSpPr/>
+          <p:nvPr/>
+        </p:nvSpPr>
+        <p:spPr>
+          <a:xfrm>
+            <a:off x="548640" y="320040"/>
+            <a:ext cx="10972800" cy="502920"/>
+          </a:xfrm>
+          <a:prstGeom prst="rect">
+            <a:avLst/>
+          </a:prstGeom>
+          <a:noFill/>
+          <a:ln/>
+        </p:spPr>
+        <p:txBody>
+          <a:bodyPr wrap="square" rtlCol="0" anchor="ctr"/>
+          <a:lstStyle/>
+          <a:p>
+            <a:pPr indent="0" marL="0">
+              <a:buNone/>
+            </a:pPr>
+            <a:r>
+              <a:rPr lang="en-US" sz="2800" b="1" dirty="0">
+                <a:solidFill>
+                  <a:srgbClr val="CDD6F4"/>
+                </a:solidFill>
+                <a:latin typeface="Calibri" pitchFamily="34" charset="0"/>
+                <a:ea typeface="Calibri" pitchFamily="34" charset="-122"/>
+                <a:cs typeface="Calibri" pitchFamily="34" charset="-120"/>
+              </a:rPr>
+              <a:t>Packages &amp; libraries</a:t>
+            </a:r>
+            <a:endParaRPr lang="en-US" sz="2800" dirty="0"/>
+          </a:p>
+        </p:txBody>
+      </p:sp>
+      <p:sp>
+        <p:nvSpPr>
+          <p:cNvPr id="4" name="Text 2"/>
+          <p:cNvSpPr/>
+          <p:nvPr/>
+        </p:nvSpPr>
+        <p:spPr>
+          <a:xfrm>
+            <a:off x="548640" y="822960"/>
+            <a:ext cx="10972800" cy="320040"/>
+          </a:xfrm>
+          <a:prstGeom prst="rect">
+            <a:avLst/>
+          </a:prstGeom>
+          <a:noFill/>
+          <a:ln/>
+        </p:spPr>
+        <p:txBody>
+          <a:bodyPr wrap="square" rtlCol="0" anchor="ctr"/>
+          <a:lstStyle/>
+          <a:p>
+            <a:pPr indent="0" marL="0">
+              <a:buNone/>
+            </a:pPr>
+            <a:r>
+              <a:rPr lang="en-US" sz="1400" dirty="0">
+                <a:solidFill>
+                  <a:srgbClr val="94E2D5"/>
+                </a:solidFill>
+                <a:latin typeface="Calibri" pitchFamily="34" charset="0"/>
+                <a:ea typeface="Calibri" pitchFamily="34" charset="-122"/>
+                <a:cs typeface="Calibri" pitchFamily="34" charset="-120"/>
+              </a:rPr>
+              <a:t>Node.js packages · Cordova · vendored UI (docs/packages.md)</a:t>
+            </a:r>
+            <a:endParaRPr lang="en-US" sz="1400" dirty="0"/>
+          </a:p>
+        </p:txBody>
+      </p:sp>
+      <p:sp>
+        <p:nvSpPr>
+          <p:cNvPr id="5" name="Shape 3"/>
+          <p:cNvSpPr/>
+          <p:nvPr/>
+        </p:nvSpPr>
+        <p:spPr>
+          <a:xfrm>
+            <a:off x="457200" y="1325880"/>
+            <a:ext cx="3566160" cy="4663440"/>
+          </a:xfrm>
+          <a:prstGeom prst="roundRect">
+            <a:avLst>
+              <a:gd name="adj" fmla="val 2051"/>
+            </a:avLst>
+          </a:prstGeom>
+          <a:solidFill>
+            <a:srgbClr val="181825"/>
+          </a:solidFill>
+          <a:ln/>
+        </p:spPr>
+      </p:sp>
+      <p:sp>
+        <p:nvSpPr>
+          <p:cNvPr id="6" name="Shape 4"/>
+          <p:cNvSpPr/>
+          <p:nvPr/>
+        </p:nvSpPr>
+        <p:spPr>
+          <a:xfrm>
+            <a:off x="457200" y="1325880"/>
+            <a:ext cx="3566160" cy="109728"/>
           </a:xfrm>
           <a:prstGeom prst="rect">
             <a:avLst/>
@@ -1910,6 +2099,688 @@
       </p:sp>
       <p:sp>
         <p:nvSpPr>
+          <p:cNvPr id="7" name="Text 5"/>
+          <p:cNvSpPr/>
+          <p:nvPr/>
+        </p:nvSpPr>
+        <p:spPr>
+          <a:xfrm>
+            <a:off x="640080" y="1554480"/>
+            <a:ext cx="3200400" cy="411480"/>
+          </a:xfrm>
+          <a:prstGeom prst="rect">
+            <a:avLst/>
+          </a:prstGeom>
+          <a:noFill/>
+          <a:ln/>
+        </p:spPr>
+        <p:txBody>
+          <a:bodyPr wrap="square" rtlCol="0" anchor="ctr"/>
+          <a:lstStyle/>
+          <a:p>
+            <a:pPr indent="0" marL="0">
+              <a:buNone/>
+            </a:pPr>
+            <a:r>
+              <a:rPr lang="en-US" sz="1800" b="1" dirty="0">
+                <a:solidFill>
+                  <a:srgbClr val="94E2D5"/>
+                </a:solidFill>
+                <a:latin typeface="Calibri" pitchFamily="34" charset="0"/>
+                <a:ea typeface="Calibri" pitchFamily="34" charset="-122"/>
+                <a:cs typeface="Calibri" pitchFamily="34" charset="-120"/>
+              </a:rPr>
+              <a:t>Server (npm)</a:t>
+            </a:r>
+            <a:endParaRPr lang="en-US" sz="1800" dirty="0"/>
+          </a:p>
+        </p:txBody>
+      </p:sp>
+      <p:sp>
+        <p:nvSpPr>
+          <p:cNvPr id="8" name="Text 6"/>
+          <p:cNvSpPr/>
+          <p:nvPr/>
+        </p:nvSpPr>
+        <p:spPr>
+          <a:xfrm>
+            <a:off x="640080" y="2103120"/>
+            <a:ext cx="3200400" cy="3566160"/>
+          </a:xfrm>
+          <a:prstGeom prst="rect">
+            <a:avLst/>
+          </a:prstGeom>
+          <a:noFill/>
+          <a:ln/>
+        </p:spPr>
+        <p:txBody>
+          <a:bodyPr wrap="square" rtlCol="0" anchor="t"/>
+          <a:lstStyle/>
+          <a:p>
+            <a:pPr indent="0" marL="0">
+              <a:buNone/>
+            </a:pPr>
+            <a:r>
+              <a:rPr lang="en-US" sz="1500" dirty="0">
+                <a:solidFill>
+                  <a:srgbClr val="CDD6F4"/>
+                </a:solidFill>
+                <a:latin typeface="Calibri" pitchFamily="34" charset="0"/>
+                <a:ea typeface="Calibri" pitchFamily="34" charset="-122"/>
+                <a:cs typeface="Calibri" pitchFamily="34" charset="-120"/>
+              </a:rPr>
+              <a:t>express · mongoose</a:t>
+            </a:r>
+            <a:endParaRPr lang="en-US" sz="1500" dirty="0"/>
+          </a:p>
+          <a:p>
+            <a:pPr indent="0" marL="0">
+              <a:buNone/>
+            </a:pPr>
+            <a:r>
+              <a:rPr lang="en-US" sz="1500" dirty="0">
+                <a:solidFill>
+                  <a:srgbClr val="CDD6F4"/>
+                </a:solidFill>
+                <a:latin typeface="Calibri" pitchFamily="34" charset="0"/>
+                <a:ea typeface="Calibri" pitchFamily="34" charset="-122"/>
+                <a:cs typeface="Calibri" pitchFamily="34" charset="-120"/>
+              </a:rPr>
+              <a:t>passport + local/JWT</a:t>
+            </a:r>
+            <a:endParaRPr lang="en-US" sz="1500" dirty="0"/>
+          </a:p>
+          <a:p>
+            <a:pPr indent="0" marL="0">
+              <a:buNone/>
+            </a:pPr>
+            <a:r>
+              <a:rPr lang="en-US" sz="1500" dirty="0">
+                <a:solidFill>
+                  <a:srgbClr val="CDD6F4"/>
+                </a:solidFill>
+                <a:latin typeface="Calibri" pitchFamily="34" charset="0"/>
+                <a:ea typeface="Calibri" pitchFamily="34" charset="-122"/>
+                <a:cs typeface="Calibri" pitchFamily="34" charset="-120"/>
+              </a:rPr>
+              <a:t>jsonwebtoken · bcrypt</a:t>
+            </a:r>
+            <a:endParaRPr lang="en-US" sz="1500" dirty="0"/>
+          </a:p>
+          <a:p>
+            <a:pPr indent="0" marL="0">
+              <a:buNone/>
+            </a:pPr>
+            <a:r>
+              <a:rPr lang="en-US" sz="1500" dirty="0">
+                <a:solidFill>
+                  <a:srgbClr val="CDD6F4"/>
+                </a:solidFill>
+                <a:latin typeface="Calibri" pitchFamily="34" charset="0"/>
+                <a:ea typeface="Calibri" pitchFamily="34" charset="-122"/>
+                <a:cs typeface="Calibri" pitchFamily="34" charset="-120"/>
+              </a:rPr>
+              <a:t>cors · dotenv</a:t>
+            </a:r>
+            <a:endParaRPr lang="en-US" sz="1500" dirty="0"/>
+          </a:p>
+          <a:p>
+            <a:pPr indent="0" marL="0">
+              <a:buNone/>
+            </a:pPr>
+            <a:r>
+              <a:rPr lang="en-US" sz="1500" dirty="0">
+                <a:solidFill>
+                  <a:srgbClr val="CDD6F4"/>
+                </a:solidFill>
+                <a:latin typeface="Calibri" pitchFamily="34" charset="0"/>
+                <a:ea typeface="Calibri" pitchFamily="34" charset="-122"/>
+                <a:cs typeface="Calibri" pitchFamily="34" charset="-120"/>
+              </a:rPr>
+              <a:t>Dev: vitest, supertest,</a:t>
+            </a:r>
+            <a:endParaRPr lang="en-US" sz="1500" dirty="0"/>
+          </a:p>
+          <a:p>
+            <a:pPr indent="0" marL="0">
+              <a:buNone/>
+            </a:pPr>
+            <a:r>
+              <a:rPr lang="en-US" sz="1500" dirty="0">
+                <a:solidFill>
+                  <a:srgbClr val="CDD6F4"/>
+                </a:solidFill>
+                <a:latin typeface="Calibri" pitchFamily="34" charset="0"/>
+                <a:ea typeface="Calibri" pitchFamily="34" charset="-122"/>
+                <a:cs typeface="Calibri" pitchFamily="34" charset="-120"/>
+              </a:rPr>
+              <a:t>nodemon, oxlint/oxfmt</a:t>
+            </a:r>
+            <a:endParaRPr lang="en-US" sz="1500" dirty="0"/>
+          </a:p>
+        </p:txBody>
+      </p:sp>
+      <p:sp>
+        <p:nvSpPr>
+          <p:cNvPr id="9" name="Shape 7"/>
+          <p:cNvSpPr/>
+          <p:nvPr/>
+        </p:nvSpPr>
+        <p:spPr>
+          <a:xfrm>
+            <a:off x="4297680" y="1325880"/>
+            <a:ext cx="3566160" cy="4663440"/>
+          </a:xfrm>
+          <a:prstGeom prst="roundRect">
+            <a:avLst>
+              <a:gd name="adj" fmla="val 2051"/>
+            </a:avLst>
+          </a:prstGeom>
+          <a:solidFill>
+            <a:srgbClr val="181825"/>
+          </a:solidFill>
+          <a:ln/>
+        </p:spPr>
+      </p:sp>
+      <p:sp>
+        <p:nvSpPr>
+          <p:cNvPr id="10" name="Shape 8"/>
+          <p:cNvSpPr/>
+          <p:nvPr/>
+        </p:nvSpPr>
+        <p:spPr>
+          <a:xfrm>
+            <a:off x="4297680" y="1325880"/>
+            <a:ext cx="3566160" cy="109728"/>
+          </a:xfrm>
+          <a:prstGeom prst="rect">
+            <a:avLst/>
+          </a:prstGeom>
+          <a:solidFill>
+            <a:srgbClr val="89B4FA"/>
+          </a:solidFill>
+          <a:ln/>
+        </p:spPr>
+      </p:sp>
+      <p:sp>
+        <p:nvSpPr>
+          <p:cNvPr id="11" name="Text 9"/>
+          <p:cNvSpPr/>
+          <p:nvPr/>
+        </p:nvSpPr>
+        <p:spPr>
+          <a:xfrm>
+            <a:off x="4480560" y="1554480"/>
+            <a:ext cx="3200400" cy="411480"/>
+          </a:xfrm>
+          <a:prstGeom prst="rect">
+            <a:avLst/>
+          </a:prstGeom>
+          <a:noFill/>
+          <a:ln/>
+        </p:spPr>
+        <p:txBody>
+          <a:bodyPr wrap="square" rtlCol="0" anchor="ctr"/>
+          <a:lstStyle/>
+          <a:p>
+            <a:pPr indent="0" marL="0">
+              <a:buNone/>
+            </a:pPr>
+            <a:r>
+              <a:rPr lang="en-US" sz="1800" b="1" dirty="0">
+                <a:solidFill>
+                  <a:srgbClr val="89B4FA"/>
+                </a:solidFill>
+                <a:latin typeface="Calibri" pitchFamily="34" charset="0"/>
+                <a:ea typeface="Calibri" pitchFamily="34" charset="-122"/>
+                <a:cs typeface="Calibri" pitchFamily="34" charset="-120"/>
+              </a:rPr>
+              <a:t>Cordova (npm)</a:t>
+            </a:r>
+            <a:endParaRPr lang="en-US" sz="1800" dirty="0"/>
+          </a:p>
+        </p:txBody>
+      </p:sp>
+      <p:sp>
+        <p:nvSpPr>
+          <p:cNvPr id="12" name="Text 10"/>
+          <p:cNvSpPr/>
+          <p:nvPr/>
+        </p:nvSpPr>
+        <p:spPr>
+          <a:xfrm>
+            <a:off x="4480560" y="2103120"/>
+            <a:ext cx="3200400" cy="3566160"/>
+          </a:xfrm>
+          <a:prstGeom prst="rect">
+            <a:avLst/>
+          </a:prstGeom>
+          <a:noFill/>
+          <a:ln/>
+        </p:spPr>
+        <p:txBody>
+          <a:bodyPr wrap="square" rtlCol="0" anchor="t"/>
+          <a:lstStyle/>
+          <a:p>
+            <a:pPr indent="0" marL="0">
+              <a:buNone/>
+            </a:pPr>
+            <a:r>
+              <a:rPr lang="en-US" sz="1500" dirty="0">
+                <a:solidFill>
+                  <a:srgbClr val="CDD6F4"/>
+                </a:solidFill>
+                <a:latin typeface="Calibri" pitchFamily="34" charset="0"/>
+                <a:ea typeface="Calibri" pitchFamily="34" charset="-122"/>
+                <a:cs typeface="Calibri" pitchFamily="34" charset="-120"/>
+              </a:rPr>
+              <a:t>cordova (CLI)</a:t>
+            </a:r>
+            <a:endParaRPr lang="en-US" sz="1500" dirty="0"/>
+          </a:p>
+          <a:p>
+            <a:pPr indent="0" marL="0">
+              <a:buNone/>
+            </a:pPr>
+            <a:r>
+              <a:rPr lang="en-US" sz="1500" dirty="0">
+                <a:solidFill>
+                  <a:srgbClr val="CDD6F4"/>
+                </a:solidFill>
+                <a:latin typeface="Calibri" pitchFamily="34" charset="0"/>
+                <a:ea typeface="Calibri" pitchFamily="34" charset="-122"/>
+                <a:cs typeface="Calibri" pitchFamily="34" charset="-120"/>
+              </a:rPr>
+              <a:t>cordova-android</a:t>
+            </a:r>
+            <a:endParaRPr lang="en-US" sz="1500" dirty="0"/>
+          </a:p>
+          <a:p>
+            <a:pPr indent="0" marL="0">
+              <a:buNone/>
+            </a:pPr>
+            <a:r>
+              <a:rPr lang="en-US" sz="1500" dirty="0">
+                <a:solidFill>
+                  <a:srgbClr val="CDD6F4"/>
+                </a:solidFill>
+                <a:latin typeface="Calibri" pitchFamily="34" charset="0"/>
+                <a:ea typeface="Calibri" pitchFamily="34" charset="-122"/>
+                <a:cs typeface="Calibri" pitchFamily="34" charset="-120"/>
+              </a:rPr>
+              <a:t>cordova-plugin-camera</a:t>
+            </a:r>
+            <a:endParaRPr lang="en-US" sz="1500" dirty="0"/>
+          </a:p>
+          <a:p>
+            <a:pPr indent="0" marL="0">
+              <a:buNone/>
+            </a:pPr>
+            <a:r>
+              <a:rPr lang="en-US" sz="1500" dirty="0">
+                <a:solidFill>
+                  <a:srgbClr val="CDD6F4"/>
+                </a:solidFill>
+                <a:latin typeface="Calibri" pitchFamily="34" charset="0"/>
+                <a:ea typeface="Calibri" pitchFamily="34" charset="-122"/>
+                <a:cs typeface="Calibri" pitchFamily="34" charset="-120"/>
+              </a:rPr>
+              <a:t>Listing photos on</a:t>
+            </a:r>
+            <a:endParaRPr lang="en-US" sz="1500" dirty="0"/>
+          </a:p>
+          <a:p>
+            <a:pPr indent="0" marL="0">
+              <a:buNone/>
+            </a:pPr>
+            <a:r>
+              <a:rPr lang="en-US" sz="1500" dirty="0">
+                <a:solidFill>
+                  <a:srgbClr val="CDD6F4"/>
+                </a:solidFill>
+                <a:latin typeface="Calibri" pitchFamily="34" charset="0"/>
+                <a:ea typeface="Calibri" pitchFamily="34" charset="-122"/>
+                <a:cs typeface="Calibri" pitchFamily="34" charset="-120"/>
+              </a:rPr>
+              <a:t>device / emulator</a:t>
+            </a:r>
+            <a:endParaRPr lang="en-US" sz="1500" dirty="0"/>
+          </a:p>
+        </p:txBody>
+      </p:sp>
+      <p:sp>
+        <p:nvSpPr>
+          <p:cNvPr id="13" name="Shape 11"/>
+          <p:cNvSpPr/>
+          <p:nvPr/>
+        </p:nvSpPr>
+        <p:spPr>
+          <a:xfrm>
+            <a:off x="8138160" y="1325880"/>
+            <a:ext cx="3566160" cy="4663440"/>
+          </a:xfrm>
+          <a:prstGeom prst="roundRect">
+            <a:avLst>
+              <a:gd name="adj" fmla="val 2051"/>
+            </a:avLst>
+          </a:prstGeom>
+          <a:solidFill>
+            <a:srgbClr val="181825"/>
+          </a:solidFill>
+          <a:ln/>
+        </p:spPr>
+      </p:sp>
+      <p:sp>
+        <p:nvSpPr>
+          <p:cNvPr id="14" name="Shape 12"/>
+          <p:cNvSpPr/>
+          <p:nvPr/>
+        </p:nvSpPr>
+        <p:spPr>
+          <a:xfrm>
+            <a:off x="8138160" y="1325880"/>
+            <a:ext cx="3566160" cy="109728"/>
+          </a:xfrm>
+          <a:prstGeom prst="rect">
+            <a:avLst/>
+          </a:prstGeom>
+          <a:solidFill>
+            <a:srgbClr val="FAB387"/>
+          </a:solidFill>
+          <a:ln/>
+        </p:spPr>
+      </p:sp>
+      <p:sp>
+        <p:nvSpPr>
+          <p:cNvPr id="15" name="Text 13"/>
+          <p:cNvSpPr/>
+          <p:nvPr/>
+        </p:nvSpPr>
+        <p:spPr>
+          <a:xfrm>
+            <a:off x="8321040" y="1554480"/>
+            <a:ext cx="3200400" cy="411480"/>
+          </a:xfrm>
+          <a:prstGeom prst="rect">
+            <a:avLst/>
+          </a:prstGeom>
+          <a:noFill/>
+          <a:ln/>
+        </p:spPr>
+        <p:txBody>
+          <a:bodyPr wrap="square" rtlCol="0" anchor="ctr"/>
+          <a:lstStyle/>
+          <a:p>
+            <a:pPr indent="0" marL="0">
+              <a:buNone/>
+            </a:pPr>
+            <a:r>
+              <a:rPr lang="en-US" sz="1800" b="1" dirty="0">
+                <a:solidFill>
+                  <a:srgbClr val="FAB387"/>
+                </a:solidFill>
+                <a:latin typeface="Calibri" pitchFamily="34" charset="0"/>
+                <a:ea typeface="Calibri" pitchFamily="34" charset="-122"/>
+                <a:cs typeface="Calibri" pitchFamily="34" charset="-120"/>
+              </a:rPr>
+              <a:t>Client (vendored)</a:t>
+            </a:r>
+            <a:endParaRPr lang="en-US" sz="1800" dirty="0"/>
+          </a:p>
+        </p:txBody>
+      </p:sp>
+      <p:sp>
+        <p:nvSpPr>
+          <p:cNvPr id="16" name="Text 14"/>
+          <p:cNvSpPr/>
+          <p:nvPr/>
+        </p:nvSpPr>
+        <p:spPr>
+          <a:xfrm>
+            <a:off x="8321040" y="2103120"/>
+            <a:ext cx="3200400" cy="3566160"/>
+          </a:xfrm>
+          <a:prstGeom prst="rect">
+            <a:avLst/>
+          </a:prstGeom>
+          <a:noFill/>
+          <a:ln/>
+        </p:spPr>
+        <p:txBody>
+          <a:bodyPr wrap="square" rtlCol="0" anchor="t"/>
+          <a:lstStyle/>
+          <a:p>
+            <a:pPr indent="0" marL="0">
+              <a:buNone/>
+            </a:pPr>
+            <a:r>
+              <a:rPr lang="en-US" sz="1500" dirty="0">
+                <a:solidFill>
+                  <a:srgbClr val="CDD6F4"/>
+                </a:solidFill>
+                <a:latin typeface="Calibri" pitchFamily="34" charset="0"/>
+                <a:ea typeface="Calibri" pitchFamily="34" charset="-122"/>
+                <a:cs typeface="Calibri" pitchFamily="34" charset="-120"/>
+              </a:rPr>
+              <a:t>jQuery 2.2.4</a:t>
+            </a:r>
+            <a:endParaRPr lang="en-US" sz="1500" dirty="0"/>
+          </a:p>
+          <a:p>
+            <a:pPr indent="0" marL="0">
+              <a:buNone/>
+            </a:pPr>
+            <a:r>
+              <a:rPr lang="en-US" sz="1500" dirty="0">
+                <a:solidFill>
+                  <a:srgbClr val="CDD6F4"/>
+                </a:solidFill>
+                <a:latin typeface="Calibri" pitchFamily="34" charset="0"/>
+                <a:ea typeface="Calibri" pitchFamily="34" charset="-122"/>
+                <a:cs typeface="Calibri" pitchFamily="34" charset="-120"/>
+              </a:rPr>
+              <a:t>jQuery Mobile 1.4.5</a:t>
+            </a:r>
+            <a:endParaRPr lang="en-US" sz="1500" dirty="0"/>
+          </a:p>
+          <a:p>
+            <a:pPr indent="0" marL="0">
+              <a:buNone/>
+            </a:pPr>
+            <a:r>
+              <a:rPr lang="en-US" sz="1500" dirty="0">
+                <a:solidFill>
+                  <a:srgbClr val="CDD6F4"/>
+                </a:solidFill>
+                <a:latin typeface="Calibri" pitchFamily="34" charset="0"/>
+                <a:ea typeface="Calibri" pitchFamily="34" charset="-122"/>
+                <a:cs typeface="Calibri" pitchFamily="34" charset="-120"/>
+              </a:rPr>
+              <a:t>(under www/lib/)</a:t>
+            </a:r>
+            <a:endParaRPr lang="en-US" sz="1500" dirty="0"/>
+          </a:p>
+          <a:p>
+            <a:pPr indent="0" marL="0">
+              <a:buNone/>
+            </a:pPr>
+            <a:r>
+              <a:rPr lang="en-US" sz="1500" dirty="0">
+                <a:solidFill>
+                  <a:srgbClr val="CDD6F4"/>
+                </a:solidFill>
+                <a:latin typeface="Calibri" pitchFamily="34" charset="0"/>
+                <a:ea typeface="Calibri" pitchFamily="34" charset="-122"/>
+                <a:cs typeface="Calibri" pitchFamily="34" charset="-120"/>
+              </a:rPr>
+              <a:t>No transpile step</a:t>
+            </a:r>
+            <a:endParaRPr lang="en-US" sz="1500" dirty="0"/>
+          </a:p>
+          <a:p>
+            <a:pPr indent="0" marL="0">
+              <a:buNone/>
+            </a:pPr>
+            <a:r>
+              <a:rPr lang="en-US" sz="1500" dirty="0">
+                <a:solidFill>
+                  <a:srgbClr val="CDD6F4"/>
+                </a:solidFill>
+                <a:latin typeface="Calibri" pitchFamily="34" charset="0"/>
+                <a:ea typeface="Calibri" pitchFamily="34" charset="-122"/>
+                <a:cs typeface="Calibri" pitchFamily="34" charset="-120"/>
+              </a:rPr>
+              <a:t>for day-to-day UI</a:t>
+            </a:r>
+            <a:endParaRPr lang="en-US" sz="1500" dirty="0"/>
+          </a:p>
+        </p:txBody>
+      </p:sp>
+      <p:sp>
+        <p:nvSpPr>
+          <p:cNvPr id="17" name="Text 15"/>
+          <p:cNvSpPr/>
+          <p:nvPr/>
+        </p:nvSpPr>
+        <p:spPr>
+          <a:xfrm>
+            <a:off x="457200" y="6446520"/>
+            <a:ext cx="9144000" cy="274320"/>
+          </a:xfrm>
+          <a:prstGeom prst="rect">
+            <a:avLst/>
+          </a:prstGeom>
+          <a:noFill/>
+          <a:ln/>
+        </p:spPr>
+        <p:txBody>
+          <a:bodyPr wrap="square" rtlCol="0" anchor="ctr"/>
+          <a:lstStyle/>
+          <a:p>
+            <a:pPr indent="0" marL="0">
+              <a:buNone/>
+            </a:pPr>
+            <a:r>
+              <a:rPr lang="en-US" sz="1100" dirty="0">
+                <a:solidFill>
+                  <a:srgbClr val="A6ADC8"/>
+                </a:solidFill>
+                <a:latin typeface="Calibri" pitchFamily="34" charset="0"/>
+                <a:ea typeface="Calibri" pitchFamily="34" charset="-122"/>
+                <a:cs typeface="Calibri" pitchFamily="34" charset="-120"/>
+              </a:rPr>
+              <a:t>StudySwap · COIT20269 · Group D</a:t>
+            </a:r>
+            <a:endParaRPr lang="en-US" sz="1100" dirty="0"/>
+          </a:p>
+        </p:txBody>
+      </p:sp>
+      <p:sp>
+        <p:nvSpPr>
+          <p:cNvPr id="18" name="Text 16"/>
+          <p:cNvSpPr/>
+          <p:nvPr/>
+        </p:nvSpPr>
+        <p:spPr>
+          <a:xfrm>
+            <a:off x="10515600" y="6446520"/>
+            <a:ext cx="1188720" cy="274320"/>
+          </a:xfrm>
+          <a:prstGeom prst="rect">
+            <a:avLst/>
+          </a:prstGeom>
+          <a:noFill/>
+          <a:ln/>
+        </p:spPr>
+        <p:txBody>
+          <a:bodyPr wrap="square" rtlCol="0" anchor="ctr"/>
+          <a:lstStyle/>
+          <a:p>
+            <a:pPr algn="r" indent="0" marL="0">
+              <a:buNone/>
+            </a:pPr>
+            <a:r>
+              <a:rPr lang="en-US" sz="1100" dirty="0">
+                <a:solidFill>
+                  <a:srgbClr val="A6ADC8"/>
+                </a:solidFill>
+                <a:latin typeface="Calibri" pitchFamily="34" charset="0"/>
+                <a:ea typeface="Calibri" pitchFamily="34" charset="-122"/>
+                <a:cs typeface="Calibri" pitchFamily="34" charset="-120"/>
+              </a:rPr>
+              <a:t>10 / 11</a:t>
+            </a:r>
+            <a:endParaRPr lang="en-US" sz="1100" dirty="0"/>
+          </a:p>
+        </p:txBody>
+      </p:sp>
+    </p:spTree>
+  </p:cSld>
+  <p:clrMapOvr>
+    <a:masterClrMapping/>
+  </p:clrMapOvr>
+</p:sld>
+</file>
+
+<file path=ppt/slides/slide11.xml><?xml version="1.0" encoding="utf-8"?>
+<p:sld xmlns:a="http://schemas.openxmlformats.org/drawingml/2006/main" xmlns:r="http://schemas.openxmlformats.org/officeDocument/2006/relationships" xmlns:p="http://schemas.openxmlformats.org/presentationml/2006/main">
+  <p:cSld name="Slide 11">
+    <p:spTree>
+      <p:nvGrpSpPr>
+        <p:cNvPr id="1" name=""/>
+        <p:cNvGrpSpPr/>
+        <p:nvPr/>
+      </p:nvGrpSpPr>
+      <p:grpSpPr>
+        <a:xfrm>
+          <a:off x="0" y="0"/>
+          <a:ext cx="0" cy="0"/>
+          <a:chOff x="0" y="0"/>
+          <a:chExt cx="0" cy="0"/>
+        </a:xfrm>
+      </p:grpSpPr>
+      <p:sp>
+        <p:nvSpPr>
+          <p:cNvPr id="2" name="Shape 0"/>
+          <p:cNvSpPr/>
+          <p:nvPr/>
+        </p:nvSpPr>
+        <p:spPr>
+          <a:xfrm>
+            <a:off x="0" y="0"/>
+            <a:ext cx="12191695" cy="6858000"/>
+          </a:xfrm>
+          <a:prstGeom prst="rect">
+            <a:avLst/>
+          </a:prstGeom>
+          <a:solidFill>
+            <a:srgbClr val="1E1E2E"/>
+          </a:solidFill>
+          <a:ln/>
+        </p:spPr>
+      </p:sp>
+      <p:sp>
+        <p:nvSpPr>
+          <p:cNvPr id="3" name="Shape 1"/>
+          <p:cNvSpPr/>
+          <p:nvPr/>
+        </p:nvSpPr>
+        <p:spPr>
+          <a:xfrm>
+            <a:off x="0" y="0"/>
+            <a:ext cx="228600" cy="6858000"/>
+          </a:xfrm>
+          <a:prstGeom prst="rect">
+            <a:avLst/>
+          </a:prstGeom>
+          <a:solidFill>
+            <a:srgbClr val="94E2D5"/>
+          </a:solidFill>
+          <a:ln/>
+        </p:spPr>
+      </p:sp>
+      <p:sp>
+        <p:nvSpPr>
           <p:cNvPr id="4" name="Text 2"/>
           <p:cNvSpPr/>
           <p:nvPr/>
@@ -2036,7 +2907,7 @@
                 <a:ea typeface="Calibri" pitchFamily="34" charset="-122"/>
                 <a:cs typeface="Calibri" pitchFamily="34" charset="-120"/>
               </a:rPr>
-              <a:t>Repo: client/ · server/ · docs/   |   Sources: user-stories, api-contract, vulnerability-analysis</a:t>
+              <a:t>Repo: client/ · server/ · docs/   |   Sources: user-stories, api-contract, packages, vulnerability-analysis</a:t>
             </a:r>
             <a:endParaRPr lang="en-US" sz="1400" dirty="0"/>
           </a:p>
@@ -2114,7 +2985,7 @@
                 <a:ea typeface="Calibri" pitchFamily="34" charset="-122"/>
                 <a:cs typeface="Calibri" pitchFamily="34" charset="-120"/>
               </a:rPr>
-              <a:t>10 / 10</a:t>
+              <a:t>11 / 11</a:t>
             </a:r>
             <a:endParaRPr lang="en-US" sz="1100" dirty="0"/>
           </a:p>
@@ -2343,7 +3214,7 @@
                 <a:ea typeface="Calibri" pitchFamily="34" charset="-122"/>
                 <a:cs typeface="Calibri" pitchFamily="34" charset="-120"/>
               </a:rPr>
-              <a:t>Test results (preliminary) — screenshots / flows (#6 follow-up)</a:t>
+              <a:t>Packages &amp; libraries — Node.js, Cordova, vendored UI</a:t>
             </a:r>
             <a:endParaRPr lang="en-US" sz="1800" dirty="0"/>
           </a:p>
@@ -2364,7 +3235,7 @@
                 <a:ea typeface="Calibri" pitchFamily="34" charset="-122"/>
                 <a:cs typeface="Calibri" pitchFamily="34" charset="-120"/>
               </a:rPr>
-              <a:t>Vulnerability analysis (preliminary) — identify &amp; report only</a:t>
+              <a:t>Test results (preliminary) — screenshots / flows (#6 follow-up)</a:t>
             </a:r>
             <a:endParaRPr lang="en-US" sz="1800" dirty="0"/>
           </a:p>
@@ -2385,6 +3256,27 @@
                 <a:ea typeface="Calibri" pitchFamily="34" charset="-122"/>
                 <a:cs typeface="Calibri" pitchFamily="34" charset="-120"/>
               </a:rPr>
+              <a:t>Vulnerability analysis (preliminary) — identify &amp; report only</a:t>
+            </a:r>
+            <a:endParaRPr lang="en-US" sz="1800" dirty="0"/>
+          </a:p>
+          <a:p>
+            <a:pPr marL="342900" indent="-342900">
+              <a:spcAft>
+                <a:spcPts val="1000"/>
+              </a:spcAft>
+              <a:buSzPct val="100000"/>
+              <a:buChar char="•"/>
+            </a:pPr>
+            <a:r>
+              <a:rPr lang="en-US" sz="1800" dirty="0">
+                <a:solidFill>
+                  <a:srgbClr val="CDD6F4"/>
+                </a:solidFill>
+                <a:latin typeface="Calibri" pitchFamily="34" charset="0"/>
+                <a:ea typeface="Calibri" pitchFamily="34" charset="-122"/>
+                <a:cs typeface="Calibri" pitchFamily="34" charset="-120"/>
+              </a:rPr>
               <a:t>Live demo (device / emulator / browser)</a:t>
             </a:r>
             <a:endParaRPr lang="en-US" sz="1800" dirty="0"/>
@@ -2463,7 +3355,7 @@
                 <a:ea typeface="Calibri" pitchFamily="34" charset="-122"/>
                 <a:cs typeface="Calibri" pitchFamily="34" charset="-120"/>
               </a:rPr>
-              <a:t>2 / 10</a:t>
+              <a:t>2 / 11</a:t>
             </a:r>
             <a:endParaRPr lang="en-US" sz="1100" dirty="0"/>
           </a:p>
@@ -2812,7 +3704,7 @@
                 <a:ea typeface="Calibri" pitchFamily="34" charset="-122"/>
                 <a:cs typeface="Calibri" pitchFamily="34" charset="-120"/>
               </a:rPr>
-              <a:t>3 / 10</a:t>
+              <a:t>3 / 11</a:t>
             </a:r>
             <a:endParaRPr lang="en-US" sz="1100" dirty="0"/>
           </a:p>
@@ -3161,7 +4053,7 @@
                 <a:ea typeface="Calibri" pitchFamily="34" charset="-122"/>
                 <a:cs typeface="Calibri" pitchFamily="34" charset="-120"/>
               </a:rPr>
-              <a:t>4 / 10</a:t>
+              <a:t>4 / 11</a:t>
             </a:r>
             <a:endParaRPr lang="en-US" sz="1100" dirty="0"/>
           </a:p>
@@ -3885,7 +4777,7 @@
                 <a:ea typeface="Calibri" pitchFamily="34" charset="-122"/>
                 <a:cs typeface="Calibri" pitchFamily="34" charset="-120"/>
               </a:rPr>
-              <a:t>5 / 10</a:t>
+              <a:t>5 / 11</a:t>
             </a:r>
             <a:endParaRPr lang="en-US" sz="1100" dirty="0"/>
           </a:p>
@@ -4213,7 +5105,7 @@
                 <a:ea typeface="Calibri" pitchFamily="34" charset="-122"/>
                 <a:cs typeface="Calibri" pitchFamily="34" charset="-120"/>
               </a:rPr>
-              <a:t>6 / 10</a:t>
+              <a:t>6 / 11</a:t>
             </a:r>
             <a:endParaRPr lang="en-US" sz="1100" dirty="0"/>
           </a:p>
@@ -5146,7 +6038,7 @@
                 <a:ea typeface="Calibri" pitchFamily="34" charset="-122"/>
                 <a:cs typeface="Calibri" pitchFamily="34" charset="-120"/>
               </a:rPr>
-              <a:t>7 / 10</a:t>
+              <a:t>7 / 11</a:t>
             </a:r>
             <a:endParaRPr lang="en-US" sz="1100" dirty="0"/>
           </a:p>
@@ -5495,7 +6387,7 @@
                 <a:ea typeface="Calibri" pitchFamily="34" charset="-122"/>
                 <a:cs typeface="Calibri" pitchFamily="34" charset="-120"/>
               </a:rPr>
-              <a:t>8 / 10</a:t>
+              <a:t>8 / 11</a:t>
             </a:r>
             <a:endParaRPr lang="en-US" sz="1100" dirty="0"/>
           </a:p>
@@ -5844,7 +6736,7 @@
                 <a:ea typeface="Calibri" pitchFamily="34" charset="-122"/>
                 <a:cs typeface="Calibri" pitchFamily="34" charset="-120"/>
               </a:rPr>
-              <a:t>9 / 10</a:t>
+              <a:t>9 / 11</a:t>
             </a:r>
             <a:endParaRPr lang="en-US" sz="1100" dirty="0"/>
           </a:p>

</xml_diff>